<commit_message>
feat: professional settings panel, sidebar URL removed, infra diagram, PPTX — v2.0.3
- Redesigned Settings dropdown: app identity header with icon, segmented
  theme toggle, key-value release info rows, card-style support link
- Removed target URL from sidebar service items (name only)
- Added infrastructure architecture diagram (docs/infra.mmd + infra.png)
- Updated PPTX deck with infra slide (docs/PerfStack.pptx)
- Bumped version to v2.0.3 (App.jsx, main.py, README)

Co-Authored-By: Claude Sonnet 4.6 <noreply@anthropic.com>
</commit_message>
<xml_diff>
--- a/docs/PerfStack.pptx
+++ b/docs/PerfStack.pptx
@@ -15,6 +15,7 @@
     <p:sldId id="263" r:id="rId9"/>
     <p:sldId id="264" r:id="rId10"/>
     <p:sldId id="265" r:id="rId11"/>
+    <p:sldId id="266" r:id="rId12"/>
   </p:sldIdLst>
   <p:sldSz cx="12188825" cy="6858000"/>
   <p:notesSz cx="6858000" cy="9144000"/>
@@ -130,58 +131,6 @@
     </p:ext>
   </p:extLst>
 </p:presentation>
-</file>
-
-<file path=ppt/changesInfos/changesInfo1.xml><?xml version="1.0" encoding="utf-8"?>
-<pc:chgInfo xmlns:a="http://schemas.openxmlformats.org/drawingml/2006/main" xmlns:r="http://schemas.openxmlformats.org/officeDocument/2006/relationships" xmlns:ac="http://schemas.microsoft.com/office/drawing/2013/main/command" xmlns:pc="http://schemas.microsoft.com/office/powerpoint/2013/main/command">
-  <pc:docChgLst>
-    <pc:chgData name="Michel Dragonetti" userId="c06dd10d-b37a-4e16-8965-600358690c57" providerId="ADAL" clId="{2A4BE4CE-8C2B-536C-A4E5-C6BA7314B118}"/>
-    <pc:docChg chg="modSld">
-      <pc:chgData name="Michel Dragonetti" userId="c06dd10d-b37a-4e16-8965-600358690c57" providerId="ADAL" clId="{2A4BE4CE-8C2B-536C-A4E5-C6BA7314B118}" dt="2026-04-08T12:10:26.308" v="9" actId="20577"/>
-      <pc:docMkLst>
-        <pc:docMk/>
-      </pc:docMkLst>
-      <pc:sldChg chg="modSp mod">
-        <pc:chgData name="Michel Dragonetti" userId="c06dd10d-b37a-4e16-8965-600358690c57" providerId="ADAL" clId="{2A4BE4CE-8C2B-536C-A4E5-C6BA7314B118}" dt="2026-04-08T12:10:11.500" v="5" actId="20577"/>
-        <pc:sldMkLst>
-          <pc:docMk/>
-          <pc:sldMk cId="0" sldId="256"/>
-        </pc:sldMkLst>
-        <pc:spChg chg="mod">
-          <ac:chgData name="Michel Dragonetti" userId="c06dd10d-b37a-4e16-8965-600358690c57" providerId="ADAL" clId="{2A4BE4CE-8C2B-536C-A4E5-C6BA7314B118}" dt="2026-04-08T12:10:11.500" v="5" actId="20577"/>
-          <ac:spMkLst>
-            <pc:docMk/>
-            <pc:sldMk cId="0" sldId="256"/>
-            <ac:spMk id="5" creationId="{00000000-0000-0000-0000-000000000000}"/>
-          </ac:spMkLst>
-        </pc:spChg>
-        <pc:spChg chg="mod">
-          <ac:chgData name="Michel Dragonetti" userId="c06dd10d-b37a-4e16-8965-600358690c57" providerId="ADAL" clId="{2A4BE4CE-8C2B-536C-A4E5-C6BA7314B118}" dt="2026-04-08T12:10:00.812" v="1" actId="1076"/>
-          <ac:spMkLst>
-            <pc:docMk/>
-            <pc:sldMk cId="0" sldId="256"/>
-            <ac:spMk id="7" creationId="{00000000-0000-0000-0000-000000000000}"/>
-          </ac:spMkLst>
-        </pc:spChg>
-      </pc:sldChg>
-      <pc:sldChg chg="modSp mod">
-        <pc:chgData name="Michel Dragonetti" userId="c06dd10d-b37a-4e16-8965-600358690c57" providerId="ADAL" clId="{2A4BE4CE-8C2B-536C-A4E5-C6BA7314B118}" dt="2026-04-08T12:10:26.308" v="9" actId="20577"/>
-        <pc:sldMkLst>
-          <pc:docMk/>
-          <pc:sldMk cId="0" sldId="265"/>
-        </pc:sldMkLst>
-        <pc:spChg chg="mod">
-          <ac:chgData name="Michel Dragonetti" userId="c06dd10d-b37a-4e16-8965-600358690c57" providerId="ADAL" clId="{2A4BE4CE-8C2B-536C-A4E5-C6BA7314B118}" dt="2026-04-08T12:10:26.308" v="9" actId="20577"/>
-          <ac:spMkLst>
-            <pc:docMk/>
-            <pc:sldMk cId="0" sldId="265"/>
-            <ac:spMk id="7" creationId="{00000000-0000-0000-0000-000000000000}"/>
-          </ac:spMkLst>
-        </pc:spChg>
-      </pc:sldChg>
-    </pc:docChg>
-  </pc:docChgLst>
-</pc:chgInfo>
 </file>
 
 <file path=ppt/slideLayouts/slideLayout1.xml><?xml version="1.0" encoding="utf-8"?>
@@ -3300,7 +3249,7 @@
         <p:spPr>
           <a:xfrm>
             <a:off x="914400" y="2743200"/>
-            <a:ext cx="10058400" cy="1015663"/>
+            <a:ext cx="10058400" cy="1188720"/>
           </a:xfrm>
           <a:prstGeom prst="rect">
             <a:avLst/>
@@ -3315,26 +3264,13 @@
           <a:p>
             <a:pPr algn="ctr"/>
             <a:r>
-              <a:rPr lang="es-ES" sz="6000" b="1" dirty="0">
+              <a:rPr sz="6000" b="1">
                 <a:solidFill>
                   <a:srgbClr val="818CF8"/>
                 </a:solidFill>
               </a:rPr>
-              <a:t>GSA </a:t>
-            </a:r>
-            <a:r>
-              <a:rPr sz="6000" b="1" dirty="0" err="1">
-                <a:solidFill>
-                  <a:srgbClr val="818CF8"/>
-                </a:solidFill>
-              </a:rPr>
               <a:t>PerfStack</a:t>
             </a:r>
-            <a:endParaRPr sz="6000" b="1" dirty="0">
-              <a:solidFill>
-                <a:srgbClr val="818CF8"/>
-              </a:solidFill>
-            </a:endParaRPr>
           </a:p>
         </p:txBody>
       </p:sp>
@@ -3380,7 +3316,7 @@
         </p:nvSpPr>
         <p:spPr>
           <a:xfrm>
-            <a:off x="914400" y="4573525"/>
+            <a:off x="914400" y="4343400"/>
             <a:ext cx="10058400" cy="457200"/>
           </a:xfrm>
           <a:prstGeom prst="rect">
@@ -3481,6 +3417,175 @@
         </p:nvSpPr>
         <p:spPr>
           <a:xfrm>
+            <a:off x="0" y="73152"/>
+            <a:ext cx="12188952" cy="38100"/>
+          </a:xfrm>
+          <a:prstGeom prst="rect">
+            <a:avLst/>
+          </a:prstGeom>
+          <a:solidFill>
+            <a:srgbClr val="6366F1"/>
+          </a:solidFill>
+          <a:ln>
+            <a:noFill/>
+          </a:ln>
+        </p:spPr>
+        <p:style>
+          <a:lnRef idx="1">
+            <a:schemeClr val="accent1"/>
+          </a:lnRef>
+          <a:fillRef idx="3">
+            <a:schemeClr val="accent1"/>
+          </a:fillRef>
+          <a:effectRef idx="2">
+            <a:schemeClr val="accent1"/>
+          </a:effectRef>
+          <a:fontRef idx="minor">
+            <a:schemeClr val="lt1"/>
+          </a:fontRef>
+        </p:style>
+        <p:txBody>
+          <a:bodyPr rtlCol="0" anchor="ctr"/>
+          <a:lstStyle/>
+          <a:p>
+            <a:pPr algn="ctr"/>
+            <a:endParaRPr/>
+          </a:p>
+        </p:txBody>
+      </p:sp>
+      <p:sp>
+        <p:nvSpPr>
+          <p:cNvPr id="3" name="TextBox 2"/>
+          <p:cNvSpPr txBox="1"/>
+          <p:nvPr/>
+        </p:nvSpPr>
+        <p:spPr>
+          <a:xfrm>
+            <a:off x="548640" y="228600"/>
+            <a:ext cx="9144000" cy="548640"/>
+          </a:xfrm>
+          <a:prstGeom prst="rect">
+            <a:avLst/>
+          </a:prstGeom>
+          <a:noFill/>
+        </p:spPr>
+        <p:txBody>
+          <a:bodyPr wrap="square">
+            <a:spAutoFit/>
+          </a:bodyPr>
+          <a:lstStyle/>
+          <a:p>
+            <a:pPr algn="l"/>
+            <a:r>
+              <a:rPr sz="3200" b="1">
+                <a:solidFill>
+                  <a:srgbClr val="F1F5F9"/>
+                </a:solidFill>
+              </a:rPr>
+              <a:t>Infrastructure View</a:t>
+            </a:r>
+          </a:p>
+        </p:txBody>
+      </p:sp>
+      <p:sp>
+        <p:nvSpPr>
+          <p:cNvPr id="4" name="TextBox 3"/>
+          <p:cNvSpPr txBox="1"/>
+          <p:nvPr/>
+        </p:nvSpPr>
+        <p:spPr>
+          <a:xfrm>
+            <a:off x="548640" y="822960"/>
+            <a:ext cx="11430000" cy="365760"/>
+          </a:xfrm>
+          <a:prstGeom prst="rect">
+            <a:avLst/>
+          </a:prstGeom>
+          <a:noFill/>
+        </p:spPr>
+        <p:txBody>
+          <a:bodyPr wrap="square">
+            <a:spAutoFit/>
+          </a:bodyPr>
+          <a:lstStyle/>
+          <a:p>
+            <a:pPr algn="l"/>
+            <a:r>
+              <a:rPr sz="1400" b="0">
+                <a:solidFill>
+                  <a:srgbClr val="94A3B8"/>
+                </a:solidFill>
+              </a:rPr>
+              <a:t>Kubernetes resources · namespaces · CPU / RAM limits · network paths · storage</a:t>
+            </a:r>
+          </a:p>
+        </p:txBody>
+      </p:sp>
+      <p:pic>
+        <p:nvPicPr>
+          <p:cNvPr id="5" name="Picture 4" descr="infra.png"/>
+          <p:cNvPicPr>
+            <a:picLocks noChangeAspect="1"/>
+          </p:cNvPicPr>
+          <p:nvPr/>
+        </p:nvPicPr>
+        <p:blipFill>
+          <a:blip r:embed="rId2"/>
+          <a:stretch>
+            <a:fillRect/>
+          </a:stretch>
+        </p:blipFill>
+        <p:spPr>
+          <a:xfrm>
+            <a:off x="274320" y="1280160"/>
+            <a:ext cx="11612880" cy="5394960"/>
+          </a:xfrm>
+          <a:prstGeom prst="rect">
+            <a:avLst/>
+          </a:prstGeom>
+        </p:spPr>
+      </p:pic>
+    </p:spTree>
+  </p:cSld>
+  <p:clrMapOvr>
+    <a:masterClrMapping/>
+  </p:clrMapOvr>
+</p:sld>
+</file>
+
+<file path=ppt/slides/slide11.xml><?xml version="1.0" encoding="utf-8"?>
+<p:sld xmlns:a="http://schemas.openxmlformats.org/drawingml/2006/main" xmlns:r="http://schemas.openxmlformats.org/officeDocument/2006/relationships" xmlns:p="http://schemas.openxmlformats.org/presentationml/2006/main">
+  <p:cSld>
+    <p:bg>
+      <p:bgPr>
+        <a:solidFill>
+          <a:srgbClr val="0F1117"/>
+        </a:solidFill>
+        <a:effectLst/>
+      </p:bgPr>
+    </p:bg>
+    <p:spTree>
+      <p:nvGrpSpPr>
+        <p:cNvPr id="1" name=""/>
+        <p:cNvGrpSpPr/>
+        <p:nvPr/>
+      </p:nvGrpSpPr>
+      <p:grpSpPr>
+        <a:xfrm>
+          <a:off x="0" y="0"/>
+          <a:ext cx="0" cy="0"/>
+          <a:chOff x="0" y="0"/>
+          <a:chExt cx="0" cy="0"/>
+        </a:xfrm>
+      </p:grpSpPr>
+      <p:sp>
+        <p:nvSpPr>
+          <p:cNvPr id="2" name="Rectangle 1"/>
+          <p:cNvSpPr/>
+          <p:nvPr/>
+        </p:nvSpPr>
+        <p:spPr>
+          <a:xfrm>
             <a:off x="0" y="2560320"/>
             <a:ext cx="12188952" cy="1920240"/>
           </a:xfrm>
@@ -3681,8 +3786,8 @@
         </p:nvSpPr>
         <p:spPr>
           <a:xfrm>
-            <a:off x="988828" y="4553711"/>
-            <a:ext cx="10058400" cy="307777"/>
+            <a:off x="914400" y="4315968"/>
+            <a:ext cx="10058400" cy="411480"/>
           </a:xfrm>
           <a:prstGeom prst="rect">
             <a:avLst/>
@@ -3697,28 +3802,12 @@
           <a:p>
             <a:pPr algn="ctr"/>
             <a:r>
-              <a:rPr lang="es-ES" sz="1400" b="0" dirty="0">
+              <a:rPr sz="1400" b="0">
                 <a:solidFill>
                   <a:srgbClr val="6366F1"/>
                 </a:solidFill>
               </a:rPr>
-              <a:t>GSA </a:t>
-            </a:r>
-            <a:r>
-              <a:rPr sz="1400" b="0" dirty="0" err="1">
-                <a:solidFill>
-                  <a:srgbClr val="6366F1"/>
-                </a:solidFill>
-              </a:rPr>
-              <a:t>PerfStack</a:t>
-            </a:r>
-            <a:r>
-              <a:rPr sz="1400" b="0" dirty="0">
-                <a:solidFill>
-                  <a:srgbClr val="6366F1"/>
-                </a:solidFill>
-              </a:rPr>
-              <a:t> — Load Testing Platform</a:t>
+              <a:t>PerfStack — Load Testing Platform</a:t>
             </a:r>
           </a:p>
         </p:txBody>

</xml_diff>